<commit_message>
Deck: raise body-font floor to 14pt (target 16); fix flywheel/closing overlaps; correct regulatory chevron taxonomy (device vs cosmetic kit)
</commit_message>
<xml_diff>
--- a/synexo/Synapep_Investor_Deck.pptx
+++ b/synexo/Synapep_Investor_Deck.pptx
@@ -4123,7 +4123,7 @@
         <p:spPr>
           <a:xfrm>
             <a:off x="1280160" y="5943600"/>
-            <a:ext cx="9144000" cy="457200"/>
+            <a:ext cx="9601200" cy="457200"/>
           </a:xfrm>
           <a:prstGeom prst="rect">
             <a:avLst/>
@@ -4142,7 +4142,7 @@
               </a:spcAft>
             </a:pPr>
             <a:r>
-              <a:rPr sz="1200" b="0">
+              <a:rPr sz="1400" b="0">
                 <a:solidFill>
                   <a:srgbClr val="869CB4"/>
                 </a:solidFill>
@@ -4326,7 +4326,7 @@
               </a:spcAft>
             </a:pPr>
             <a:r>
-              <a:rPr sz="1200" b="0">
+              <a:rPr sz="1400" b="0">
                 <a:solidFill>
                   <a:srgbClr val="CFDDEA"/>
                 </a:solidFill>
@@ -4759,7 +4759,7 @@
               </a:spcAft>
             </a:pPr>
             <a:r>
-              <a:rPr sz="1200" b="0">
+              <a:rPr sz="1400" b="0">
                 <a:solidFill>
                   <a:srgbClr val="CFDDEA"/>
                 </a:solidFill>
@@ -5640,7 +5640,7 @@
               </a:spcAft>
             </a:pPr>
             <a:r>
-              <a:rPr sz="1200" b="0">
+              <a:rPr sz="1400" b="0">
                 <a:solidFill>
                   <a:srgbClr val="CFDDEA"/>
                 </a:solidFill>
@@ -5876,7 +5876,7 @@
               </a:spcAft>
             </a:pPr>
             <a:r>
-              <a:rPr sz="1300" b="0">
+              <a:rPr sz="1400" b="0">
                 <a:solidFill>
                   <a:srgbClr val="5A5A5A"/>
                 </a:solidFill>
@@ -6060,7 +6060,7 @@
               </a:spcAft>
             </a:pPr>
             <a:r>
-              <a:rPr sz="1200" b="0">
+              <a:rPr sz="1400" b="0">
                 <a:solidFill>
                   <a:srgbClr val="CFDDEA"/>
                 </a:solidFill>
@@ -6175,7 +6175,7 @@
           <a:p>
             <a:pPr algn="ctr"/>
             <a:r>
-              <a:rPr sz="1300" b="0">
+              <a:rPr sz="1400" b="0">
                 <a:solidFill>
                   <a:srgbClr val="CFDDEA"/>
                 </a:solidFill>
@@ -6295,7 +6295,7 @@
           <a:p>
             <a:pPr algn="ctr"/>
             <a:r>
-              <a:rPr sz="1300" b="0">
+              <a:rPr sz="1400" b="0">
                 <a:solidFill>
                   <a:srgbClr val="FFFFFF"/>
                 </a:solidFill>
@@ -6625,7 +6625,7 @@
               </a:spcAft>
             </a:pPr>
             <a:r>
-              <a:rPr sz="1200" b="0">
+              <a:rPr sz="1400" b="0">
                 <a:solidFill>
                   <a:srgbClr val="CFDDEA"/>
                 </a:solidFill>
@@ -7504,7 +7504,7 @@
               </a:spcAft>
             </a:pPr>
             <a:r>
-              <a:rPr sz="1200" b="0">
+              <a:rPr sz="1400" b="0">
                 <a:solidFill>
                   <a:srgbClr val="CFDDEA"/>
                 </a:solidFill>
@@ -8580,7 +8580,7 @@
         <p:spPr>
           <a:xfrm>
             <a:off x="1280160" y="3611880"/>
-            <a:ext cx="9875520" cy="1463040"/>
+            <a:ext cx="9875520" cy="1188720"/>
           </a:xfrm>
           <a:prstGeom prst="rect">
             <a:avLst/>
@@ -8618,7 +8618,7 @@
         </p:nvSpPr>
         <p:spPr>
           <a:xfrm>
-            <a:off x="1280160" y="5029200"/>
+            <a:off x="1280160" y="5394960"/>
             <a:ext cx="9875520" cy="640080"/>
           </a:xfrm>
           <a:prstGeom prst="rect">
@@ -8822,7 +8822,7 @@
               </a:spcAft>
             </a:pPr>
             <a:r>
-              <a:rPr sz="1200" b="0">
+              <a:rPr sz="1400" b="0">
                 <a:solidFill>
                   <a:srgbClr val="CFDDEA"/>
                 </a:solidFill>
@@ -9141,7 +9141,7 @@
               </a:spcBef>
             </a:pPr>
             <a:r>
-              <a:rPr sz="1500">
+              <a:rPr sz="1600">
                 <a:solidFill>
                   <a:srgbClr val="5A5A5A"/>
                 </a:solidFill>
@@ -9325,7 +9325,7 @@
               </a:spcAft>
             </a:pPr>
             <a:r>
-              <a:rPr sz="1200" b="0">
+              <a:rPr sz="1400" b="0">
                 <a:solidFill>
                   <a:srgbClr val="CFDDEA"/>
                 </a:solidFill>
@@ -9434,7 +9434,7 @@
               </a:spcBef>
             </a:pPr>
             <a:r>
-              <a:rPr sz="1500">
+              <a:rPr sz="1600">
                 <a:solidFill>
                   <a:srgbClr val="5A5A5A"/>
                 </a:solidFill>
@@ -9548,7 +9548,7 @@
               </a:spcBef>
             </a:pPr>
             <a:r>
-              <a:rPr sz="1500">
+              <a:rPr sz="1600">
                 <a:solidFill>
                   <a:srgbClr val="5A5A5A"/>
                 </a:solidFill>
@@ -9662,7 +9662,7 @@
               </a:spcBef>
             </a:pPr>
             <a:r>
-              <a:rPr sz="1500">
+              <a:rPr sz="1600">
                 <a:solidFill>
                   <a:srgbClr val="5A5A5A"/>
                 </a:solidFill>
@@ -9929,7 +9929,7 @@
               </a:spcAft>
             </a:pPr>
             <a:r>
-              <a:rPr sz="1200" b="0">
+              <a:rPr sz="1400" b="0">
                 <a:solidFill>
                   <a:srgbClr val="CFDDEA"/>
                 </a:solidFill>
@@ -10345,7 +10345,7 @@
               </a:spcAft>
             </a:pPr>
             <a:r>
-              <a:rPr sz="1200" b="0">
+              <a:rPr sz="1400" b="0">
                 <a:solidFill>
                   <a:srgbClr val="CFDDEA"/>
                 </a:solidFill>
@@ -10454,7 +10454,7 @@
               </a:spcBef>
             </a:pPr>
             <a:r>
-              <a:rPr sz="1500">
+              <a:rPr sz="1600">
                 <a:solidFill>
                   <a:srgbClr val="5A5A5A"/>
                 </a:solidFill>
@@ -10524,7 +10524,7 @@
               </a:spcBef>
             </a:pPr>
             <a:r>
-              <a:rPr sz="1500">
+              <a:rPr sz="1600">
                 <a:solidFill>
                   <a:srgbClr val="5A5A5A"/>
                 </a:solidFill>
@@ -10594,7 +10594,7 @@
               </a:spcBef>
             </a:pPr>
             <a:r>
-              <a:rPr sz="1500">
+              <a:rPr sz="1600">
                 <a:solidFill>
                   <a:srgbClr val="5A5A5A"/>
                 </a:solidFill>
@@ -10658,7 +10658,7 @@
           <a:p>
             <a:pPr algn="ctr"/>
             <a:r>
-              <a:rPr sz="1300" b="0">
+              <a:rPr sz="1400" b="0">
                 <a:solidFill>
                   <a:srgbClr val="CFDDEA"/>
                 </a:solidFill>
@@ -10722,7 +10722,7 @@
           <a:p>
             <a:pPr algn="ctr"/>
             <a:r>
-              <a:rPr sz="1300" b="0">
+              <a:rPr sz="1400" b="0">
                 <a:solidFill>
                   <a:srgbClr val="CFDDEA"/>
                 </a:solidFill>
@@ -10786,7 +10786,7 @@
           <a:p>
             <a:pPr algn="ctr"/>
             <a:r>
-              <a:rPr sz="1300" b="0">
+              <a:rPr sz="1400" b="0">
                 <a:solidFill>
                   <a:srgbClr val="CFDDEA"/>
                 </a:solidFill>
@@ -10850,7 +10850,7 @@
           <a:p>
             <a:pPr algn="ctr"/>
             <a:r>
-              <a:rPr sz="1300" b="0">
+              <a:rPr sz="1400" b="0">
                 <a:solidFill>
                   <a:srgbClr val="CFDDEA"/>
                 </a:solidFill>
@@ -10914,7 +10914,7 @@
           <a:p>
             <a:pPr algn="ctr"/>
             <a:r>
-              <a:rPr sz="1300" b="0">
+              <a:rPr sz="1400" b="0">
                 <a:solidFill>
                   <a:srgbClr val="CFDDEA"/>
                 </a:solidFill>
@@ -11098,7 +11098,7 @@
               </a:spcAft>
             </a:pPr>
             <a:r>
-              <a:rPr sz="1200" b="0">
+              <a:rPr sz="1400" b="0">
                 <a:solidFill>
                   <a:srgbClr val="CFDDEA"/>
                 </a:solidFill>
@@ -11156,8 +11156,8 @@
         </p:nvSpPr>
         <p:spPr>
           <a:xfrm>
-            <a:off x="4937760" y="2926079"/>
-            <a:ext cx="2103120" cy="2103120"/>
+            <a:off x="4983479" y="2606040"/>
+            <a:ext cx="2011680" cy="2011680"/>
           </a:xfrm>
           <a:prstGeom prst="ellipse">
             <a:avLst/>
@@ -11220,8 +11220,8 @@
         </p:nvSpPr>
         <p:spPr>
           <a:xfrm>
-            <a:off x="4846320" y="1554480"/>
-            <a:ext cx="2286000" cy="960120"/>
+            <a:off x="4846320" y="1325880"/>
+            <a:ext cx="2286000" cy="914400"/>
           </a:xfrm>
           <a:prstGeom prst="roundRect">
             <a:avLst/>
@@ -11253,7 +11253,7 @@
           <a:p>
             <a:pPr algn="ctr"/>
             <a:r>
-              <a:rPr sz="1500" b="1">
+              <a:rPr sz="1600" b="1">
                 <a:solidFill>
                   <a:srgbClr val="FFFFFF"/>
                 </a:solidFill>
@@ -11272,8 +11272,8 @@
         </p:nvSpPr>
         <p:spPr>
           <a:xfrm>
-            <a:off x="8778240" y="3291840"/>
-            <a:ext cx="2286000" cy="960120"/>
+            <a:off x="8549640" y="3154680"/>
+            <a:ext cx="2286000" cy="914400"/>
           </a:xfrm>
           <a:prstGeom prst="roundRect">
             <a:avLst/>
@@ -11305,7 +11305,7 @@
           <a:p>
             <a:pPr algn="ctr"/>
             <a:r>
-              <a:rPr sz="1500" b="1">
+              <a:rPr sz="1600" b="1">
                 <a:solidFill>
                   <a:srgbClr val="FFFFFF"/>
                 </a:solidFill>
@@ -11324,8 +11324,8 @@
         </p:nvSpPr>
         <p:spPr>
           <a:xfrm>
-            <a:off x="5852160" y="5486400"/>
-            <a:ext cx="2286000" cy="960120"/>
+            <a:off x="4846320" y="4937760"/>
+            <a:ext cx="2286000" cy="914400"/>
           </a:xfrm>
           <a:prstGeom prst="roundRect">
             <a:avLst/>
@@ -11357,7 +11357,7 @@
           <a:p>
             <a:pPr algn="ctr"/>
             <a:r>
-              <a:rPr sz="1500" b="1">
+              <a:rPr sz="1600" b="1">
                 <a:solidFill>
                   <a:srgbClr val="FFFFFF"/>
                 </a:solidFill>
@@ -11376,8 +11376,8 @@
         </p:nvSpPr>
         <p:spPr>
           <a:xfrm>
-            <a:off x="2194560" y="3291840"/>
-            <a:ext cx="2286000" cy="960120"/>
+            <a:off x="1143000" y="3154680"/>
+            <a:ext cx="2286000" cy="914400"/>
           </a:xfrm>
           <a:prstGeom prst="roundRect">
             <a:avLst/>
@@ -11409,7 +11409,7 @@
           <a:p>
             <a:pPr algn="ctr"/>
             <a:r>
-              <a:rPr sz="1500" b="1">
+              <a:rPr sz="1600" b="1">
                 <a:solidFill>
                   <a:srgbClr val="FFFFFF"/>
                 </a:solidFill>
@@ -11428,8 +11428,8 @@
         </p:nvSpPr>
         <p:spPr>
           <a:xfrm rot="2100000">
-            <a:off x="7040880" y="2286000"/>
-            <a:ext cx="914400" cy="502920"/>
+            <a:off x="7086600" y="2331720"/>
+            <a:ext cx="960120" cy="502920"/>
           </a:xfrm>
           <a:prstGeom prst="rightArrow">
             <a:avLst/>
@@ -11472,8 +11472,8 @@
         </p:nvSpPr>
         <p:spPr>
           <a:xfrm rot="7500000">
-            <a:off x="7315200" y="4572000"/>
-            <a:ext cx="914400" cy="502920"/>
+            <a:off x="7086600" y="4297680"/>
+            <a:ext cx="960120" cy="502920"/>
           </a:xfrm>
           <a:prstGeom prst="rightArrow">
             <a:avLst/>
@@ -11516,8 +11516,8 @@
         </p:nvSpPr>
         <p:spPr>
           <a:xfrm rot="12900000">
-            <a:off x="4206240" y="4754880"/>
-            <a:ext cx="914400" cy="502920"/>
+            <a:off x="3703320" y="4297680"/>
+            <a:ext cx="960120" cy="502920"/>
           </a:xfrm>
           <a:prstGeom prst="rightArrow">
             <a:avLst/>
@@ -11560,8 +11560,8 @@
         </p:nvSpPr>
         <p:spPr>
           <a:xfrm rot="18300000">
-            <a:off x="3931920" y="2377440"/>
-            <a:ext cx="914400" cy="502920"/>
+            <a:off x="3703320" y="2331720"/>
+            <a:ext cx="960120" cy="502920"/>
           </a:xfrm>
           <a:prstGeom prst="rightArrow">
             <a:avLst/>
@@ -11604,7 +11604,7 @@
         </p:nvSpPr>
         <p:spPr>
           <a:xfrm>
-            <a:off x="640080" y="6172200"/>
+            <a:off x="640080" y="6217920"/>
             <a:ext cx="10972800" cy="457200"/>
           </a:xfrm>
           <a:prstGeom prst="rect">
@@ -11808,7 +11808,7 @@
               </a:spcAft>
             </a:pPr>
             <a:r>
-              <a:rPr sz="1200" b="0">
+              <a:rPr sz="1400" b="0">
                 <a:solidFill>
                   <a:srgbClr val="CFDDEA"/>
                 </a:solidFill>
@@ -12287,7 +12287,7 @@
           <a:p>
             <a:pPr algn="ctr"/>
             <a:r>
-              <a:rPr sz="1300" b="1">
+              <a:rPr sz="1400" b="1">
                 <a:solidFill>
                   <a:srgbClr val="1B3355"/>
                 </a:solidFill>
@@ -12342,7 +12342,7 @@
           <a:p>
             <a:pPr algn="ctr"/>
             <a:r>
-              <a:rPr sz="1300" b="1">
+              <a:rPr sz="1400" b="1">
                 <a:solidFill>
                   <a:srgbClr val="1B3355"/>
                 </a:solidFill>
@@ -12397,7 +12397,7 @@
           <a:p>
             <a:pPr algn="ctr"/>
             <a:r>
-              <a:rPr sz="1300" b="1">
+              <a:rPr sz="1400" b="1">
                 <a:solidFill>
                   <a:srgbClr val="1B3355"/>
                 </a:solidFill>
@@ -12452,7 +12452,7 @@
           <a:p>
             <a:pPr algn="ctr"/>
             <a:r>
-              <a:rPr sz="1300" b="1">
+              <a:rPr sz="1400" b="1">
                 <a:solidFill>
                   <a:srgbClr val="1B3355"/>
                 </a:solidFill>
@@ -12507,7 +12507,7 @@
           <a:p>
             <a:pPr algn="ctr"/>
             <a:r>
-              <a:rPr sz="1300" b="1">
+              <a:rPr sz="1400" b="1">
                 <a:solidFill>
                   <a:srgbClr val="1B3355"/>
                 </a:solidFill>
@@ -12562,7 +12562,7 @@
           <a:p>
             <a:pPr algn="ctr"/>
             <a:r>
-              <a:rPr sz="1300" b="1">
+              <a:rPr sz="1400" b="1">
                 <a:solidFill>
                   <a:srgbClr val="1B3355"/>
                 </a:solidFill>
@@ -12617,7 +12617,7 @@
           <a:p>
             <a:pPr algn="ctr"/>
             <a:r>
-              <a:rPr sz="1300" b="1">
+              <a:rPr sz="1400" b="1">
                 <a:solidFill>
                   <a:srgbClr val="1B3355"/>
                 </a:solidFill>
@@ -12672,7 +12672,7 @@
           <a:p>
             <a:pPr algn="ctr"/>
             <a:r>
-              <a:rPr sz="1300" b="1">
+              <a:rPr sz="1400" b="1">
                 <a:solidFill>
                   <a:srgbClr val="1B3355"/>
                 </a:solidFill>
@@ -12727,7 +12727,7 @@
           <a:p>
             <a:pPr algn="ctr"/>
             <a:r>
-              <a:rPr sz="1300" b="1">
+              <a:rPr sz="1400" b="1">
                 <a:solidFill>
                   <a:srgbClr val="1B3355"/>
                 </a:solidFill>
@@ -12782,7 +12782,7 @@
           <a:p>
             <a:pPr algn="ctr"/>
             <a:r>
-              <a:rPr sz="1300" b="1">
+              <a:rPr sz="1400" b="1">
                 <a:solidFill>
                   <a:srgbClr val="1B3355"/>
                 </a:solidFill>
@@ -12837,7 +12837,7 @@
           <a:p>
             <a:pPr algn="ctr"/>
             <a:r>
-              <a:rPr sz="1300" b="1">
+              <a:rPr sz="1400" b="1">
                 <a:solidFill>
                   <a:srgbClr val="1B3355"/>
                 </a:solidFill>
@@ -12913,7 +12913,7 @@
           <a:p>
             <a:pPr algn="ctr"/>
             <a:r>
-              <a:rPr sz="1200" b="0">
+              <a:rPr sz="1400" b="0">
                 <a:solidFill>
                   <a:srgbClr val="CFDDEA"/>
                 </a:solidFill>
@@ -12983,7 +12983,7 @@
               </a:spcBef>
             </a:pPr>
             <a:r>
-              <a:rPr sz="1500">
+              <a:rPr sz="1600">
                 <a:solidFill>
                   <a:srgbClr val="5A5A5A"/>
                 </a:solidFill>
@@ -13053,7 +13053,7 @@
               </a:spcBef>
             </a:pPr>
             <a:r>
-              <a:rPr sz="1500">
+              <a:rPr sz="1600">
                 <a:solidFill>
                   <a:srgbClr val="5A5A5A"/>
                 </a:solidFill>
@@ -13123,7 +13123,7 @@
               </a:spcBef>
             </a:pPr>
             <a:r>
-              <a:rPr sz="1500">
+              <a:rPr sz="1600">
                 <a:solidFill>
                   <a:srgbClr val="5A5A5A"/>
                 </a:solidFill>
@@ -13193,7 +13193,7 @@
               </a:spcBef>
             </a:pPr>
             <a:r>
-              <a:rPr sz="1500">
+              <a:rPr sz="1600">
                 <a:solidFill>
                   <a:srgbClr val="5A5A5A"/>
                 </a:solidFill>
@@ -13377,7 +13377,7 @@
               </a:spcAft>
             </a:pPr>
             <a:r>
-              <a:rPr sz="1200" b="0">
+              <a:rPr sz="1400" b="0">
                 <a:solidFill>
                   <a:srgbClr val="CFDDEA"/>
                 </a:solidFill>
@@ -13435,8 +13435,8 @@
         </p:nvSpPr>
         <p:spPr>
           <a:xfrm>
-            <a:off x="640080" y="1828800"/>
-            <a:ext cx="3657600" cy="1554480"/>
+            <a:off x="640080" y="1783080"/>
+            <a:ext cx="3657600" cy="1828800"/>
           </a:xfrm>
           <a:prstGeom prst="chevron">
             <a:avLst/>
@@ -13468,7 +13468,7 @@
           <a:p>
             <a:pPr algn="ctr"/>
             <a:r>
-              <a:rPr sz="1900" b="1">
+              <a:rPr sz="1800" b="1">
                 <a:solidFill>
                   <a:srgbClr val="FFFFFF"/>
                 </a:solidFill>
@@ -13492,13 +13492,13 @@
           <a:p>
             <a:pPr algn="ctr"/>
             <a:r>
-              <a:rPr sz="1300" b="0">
+              <a:rPr sz="1400" b="0">
                 <a:solidFill>
                   <a:srgbClr val="FFFFFF"/>
                 </a:solidFill>
                 <a:latin typeface="Calibri"/>
               </a:rPr>
-              <a:t>'Modified-device' route for the microneedling/topical kit + applicator (~months)</a:t>
+              <a:t>Device family + 'modification engine' (improved-device / negative-list)</a:t>
             </a:r>
           </a:p>
         </p:txBody>
@@ -13511,8 +13511,8 @@
         </p:nvSpPr>
         <p:spPr>
           <a:xfrm>
-            <a:off x="4434840" y="1828800"/>
-            <a:ext cx="3657600" cy="1554480"/>
+            <a:off x="4434840" y="1783080"/>
+            <a:ext cx="3657600" cy="1828800"/>
           </a:xfrm>
           <a:prstGeom prst="chevron">
             <a:avLst/>
@@ -13544,7 +13544,7 @@
           <a:p>
             <a:pPr algn="ctr"/>
             <a:r>
-              <a:rPr sz="1900" b="1">
+              <a:rPr sz="1800" b="1">
                 <a:solidFill>
                   <a:srgbClr val="FFFFFF"/>
                 </a:solidFill>
@@ -13568,7 +13568,7 @@
           <a:p>
             <a:pPr algn="ctr"/>
             <a:r>
-              <a:rPr sz="1300" b="0">
+              <a:rPr sz="1400" b="0">
                 <a:solidFill>
                   <a:srgbClr val="FFFFFF"/>
                 </a:solidFill>
@@ -13587,8 +13587,8 @@
         </p:nvSpPr>
         <p:spPr>
           <a:xfrm>
-            <a:off x="8229600" y="1828800"/>
-            <a:ext cx="3657600" cy="1554480"/>
+            <a:off x="8229600" y="1783080"/>
+            <a:ext cx="3657600" cy="1828800"/>
           </a:xfrm>
           <a:prstGeom prst="chevron">
             <a:avLst/>
@@ -13620,7 +13620,7 @@
           <a:p>
             <a:pPr algn="ctr"/>
             <a:r>
-              <a:rPr sz="1900" b="1">
+              <a:rPr sz="1800" b="1">
                 <a:solidFill>
                   <a:srgbClr val="FFFFFF"/>
                 </a:solidFill>
@@ -13644,7 +13644,7 @@
           <a:p>
             <a:pPr algn="ctr"/>
             <a:r>
-              <a:rPr sz="1300" b="0">
+              <a:rPr sz="1400" b="0">
                 <a:solidFill>
                   <a:srgbClr val="FFFFFF"/>
                 </a:solidFill>
@@ -13663,8 +13663,8 @@
         </p:nvSpPr>
         <p:spPr>
           <a:xfrm>
-            <a:off x="640080" y="3931920"/>
-            <a:ext cx="10972800" cy="914400"/>
+            <a:off x="640080" y="3977639"/>
+            <a:ext cx="10972800" cy="960120"/>
           </a:xfrm>
           <a:prstGeom prst="roundRect">
             <a:avLst/>
@@ -13704,7 +13704,7 @@
                 </a:solidFill>
                 <a:latin typeface="Calibri"/>
               </a:rPr>
-              <a:t>Lead with the device family</a:t>
+              <a:t>Device vs kit — the right wrapper for each</a:t>
             </a:r>
           </a:p>
           <a:p>
@@ -13714,13 +13714,13 @@
               </a:spcBef>
             </a:pPr>
             <a:r>
-              <a:rPr sz="1500">
+              <a:rPr sz="1600">
                 <a:solidFill>
                   <a:srgbClr val="5A5A5A"/>
                 </a:solidFill>
                 <a:latin typeface="Calibri"/>
               </a:rPr>
-              <a:t>Microneedling/topical kit + applicator registers fast as a device. The IM/injectable line is likely a drug/biologic — run it on a separate, slower track so it never gates launch.</a:t>
+              <a:t>The applicator registers as a medical device; the doctor-personalised topical/exosome kits are functional-cosmetic / quasi-drug; the IM/injectable line is a separate drug/biologic that never gates launch.</a:t>
             </a:r>
           </a:p>
         </p:txBody>
@@ -13784,7 +13784,7 @@
               </a:spcBef>
             </a:pPr>
             <a:r>
-              <a:rPr sz="1500">
+              <a:rPr sz="1600">
                 <a:solidFill>
                   <a:srgbClr val="5A5A5A"/>
                 </a:solidFill>
@@ -13968,7 +13968,7 @@
               </a:spcAft>
             </a:pPr>
             <a:r>
-              <a:rPr sz="1200" b="0">
+              <a:rPr sz="1400" b="0">
                 <a:solidFill>
                   <a:srgbClr val="CFDDEA"/>
                 </a:solidFill>
@@ -14108,7 +14108,7 @@
               </a:spcAft>
             </a:pPr>
             <a:r>
-              <a:rPr sz="1300" b="0">
+              <a:rPr sz="1400" b="0">
                 <a:solidFill>
                   <a:srgbClr val="5A5A5A"/>
                 </a:solidFill>
@@ -14532,7 +14532,7 @@
               </a:spcAft>
             </a:pPr>
             <a:r>
-              <a:rPr sz="1200" b="0">
+              <a:rPr sz="1400" b="0">
                 <a:solidFill>
                   <a:srgbClr val="5A5A5A"/>
                 </a:solidFill>
@@ -14633,7 +14633,7 @@
               </a:spcAft>
             </a:pPr>
             <a:r>
-              <a:rPr sz="1300" b="0">
+              <a:rPr sz="1400" b="0">
                 <a:solidFill>
                   <a:srgbClr val="5A5A5A"/>
                 </a:solidFill>
@@ -14892,7 +14892,7 @@
               </a:spcAft>
             </a:pPr>
             <a:r>
-              <a:rPr sz="1200" b="0">
+              <a:rPr sz="1400" b="0">
                 <a:solidFill>
                   <a:srgbClr val="5A5A5A"/>
                 </a:solidFill>

</xml_diff>

<commit_message>
Reframe cold chain as resolved by stabilisation tech (cold-chain-free, ambient/2-8C) across all docs: strength not risk; DD scorecard item 3 RED->AMBER; deck/report/dossier regenerated
</commit_message>
<xml_diff>
--- a/synexo/Synapep_Investor_Deck.pptx
+++ b/synexo/Synapep_Investor_Deck.pptx
@@ -6444,7 +6444,7 @@
                 </a:solidFill>
                 <a:latin typeface="Calibri"/>
               </a:rPr>
-              <a:t>•  Cold-chain spec + COGS BOM
+              <a:t>•  Stability dossier + COGS BOM
 •  5–10 anchor clinics with reorders
 •  One prospective clinical readout
 •  Regulatory classification memo</a:t>
@@ -7569,7 +7569,7 @@
             <a:avLst/>
           </a:prstGeom>
           <a:solidFill>
-            <a:srgbClr val="C0392B"/>
+            <a:srgbClr val="1AA19C"/>
           </a:solidFill>
           <a:ln>
             <a:noFill/>
@@ -7595,13 +7595,13 @@
           <a:p>
             <a:pPr algn="ctr"/>
             <a:r>
-              <a:rPr sz="1600" b="1">
+              <a:rPr sz="2200" b="1">
                 <a:solidFill>
                   <a:srgbClr val="FFFFFF"/>
                 </a:solidFill>
                 <a:latin typeface="Calibri"/>
               </a:rPr>
-              <a:t>RED</a:t>
+              <a:t>✓</a:t>
             </a:r>
           </a:p>
         </p:txBody>
@@ -7625,7 +7625,7 @@
           </a:solidFill>
           <a:ln w="19050">
             <a:solidFill>
-              <a:srgbClr val="C0392B"/>
+              <a:srgbClr val="1AA19C"/>
             </a:solidFill>
           </a:ln>
           <a:effectLst/>
@@ -7655,7 +7655,7 @@
                   <a:srgbClr val="1B3355"/>
                 </a:solidFill>
               </a:rPr>
-              <a:t>Cold chain &amp; COGS</a:t>
+              <a:t>Cold-chain-free</a:t>
             </a:r>
           </a:p>
           <a:p>
@@ -7665,7 +7665,7 @@
                   <a:srgbClr val="5A5A5A"/>
                 </a:solidFill>
               </a:rPr>
-              <a:t>Reformulate to 2–8 °C / ambient; publish a bottom-up BOM</a:t>
+              <a:t>Stabilisation removes −80 °C; document shelf-life + bottom-up BOM</a:t>
             </a:r>
           </a:p>
         </p:txBody>

</xml_diff>